<commit_message>
Add presenter name to pitch deck, script, and viewer
Fills the remaining placeholder on slide 1 and in the script's opening
line so the deck is submission-ready.

Co-Authored-By: Claude Opus 5 <noreply@anthropic.com>
Claude-Session: https://claude.ai/code/session_01BpZQdqDUKJCNix1mZn7CYd
</commit_message>
<xml_diff>
--- a/pitch/Splendid_Spoon_Pitch_Deck.pptx
+++ b/pitch/Splendid_Spoon_Pitch_Deck.pptx
@@ -123,37 +123,37 @@
   <p:extLst>
     <p:ext uri="{521415D9-36F7-43E2-AB2F-B90AF26B5E84}">
       <p14:sectionLst xmlns:p14="http://schemas.microsoft.com/office/powerpoint/2010/main">
-        <p14:section name="Open" id="{dcf0095e-d17d-9235-056b-1939ad9fd934}">
+        <p14:section name="Open" id="{b5c4f985-0f6c-86d9-d540-ad3e5468c7a8}">
           <p14:sldIdLst>
             <p14:sldId id="256"/>
           </p14:sldIdLst>
         </p14:section>
-        <p14:section name="Situation" id="{ca35f78a-dff8-deb2-dea5-59f1a54ba7d9}">
+        <p14:section name="Situation" id="{bbf7c1be-7d12-beff-3976-0dcabe7acb6b}">
           <p14:sldIdLst>
             <p14:sldId id="257"/>
             <p14:sldId id="258"/>
             <p14:sldId id="259"/>
           </p14:sldIdLst>
         </p14:section>
-        <p14:section name="Audience" id="{74d82f2d-619f-2eb2-e0c1-1d0f6671b61c}">
+        <p14:section name="Audience" id="{590fad98-0ad7-f6ef-db85-7cacb57bab71}">
           <p14:sldIdLst>
             <p14:sldId id="260"/>
             <p14:sldId id="261"/>
           </p14:sldIdLst>
         </p14:section>
-        <p14:section name="Strategy" id="{5ea89a0a-75b8-887f-84fe-cbf33c78d0ee}">
+        <p14:section name="Strategy" id="{3aa0c4e6-224d-ec6a-da98-ed67c0a861ef}">
           <p14:sldIdLst>
             <p14:sldId id="262"/>
             <p14:sldId id="263"/>
           </p14:sldIdLst>
         </p14:section>
-        <p14:section name="Audit" id="{43e63b27-2399-cc70-bd96-20facaa05218}">
+        <p14:section name="Audit" id="{efa3feb5-81b1-1dc1-c3db-d822226b20a3}">
           <p14:sldIdLst>
             <p14:sldId id="264"/>
             <p14:sldId id="265"/>
           </p14:sldIdLst>
         </p14:section>
-        <p14:section name="Recommendation" id="{c0e85fe2-8914-82d5-87e1-2aa59cec98f0}">
+        <p14:section name="Recommendation" id="{0d5f86a2-a6a9-a5c6-72de-31a083efe72e}">
           <p14:sldIdLst>
             <p14:sldId id="266"/>
             <p14:sldId id="267"/>
@@ -161,7 +161,7 @@
             <p14:sldId id="269"/>
           </p14:sldIdLst>
         </p14:section>
-        <p14:section name="Close" id="{56700f8e-c4c4-424e-faf7-c4fa39fdb3f7}">
+        <p14:section name="Close" id="{df41b4a5-8aad-5308-c8d9-ad2fa6f37a7a}">
           <p14:sldIdLst>
             <p14:sldId id="270"/>
             <p14:sldId id="271"/>
@@ -3043,7 +3043,7 @@
             </a:pPr>
             <a:r>
               <a:rPr lang="en-US" dirty="0"/>
-              <a:t>STCO 348  ·  Strategic Communication</a:t>
+              <a:t>Jeremiah Schwarz  ·  STCO 348, Strategic Communication</a:t>
             </a:r>
             <a:endParaRPr lang="en-US" dirty="0"/>
           </a:p>

</xml_diff>

<commit_message>
Fix deck that PowerPoint refused to open
The slide 9 bar chart referenced an axis id (2094734556) that was never
declared in the chart XML. PowerPoint discards such a chart and reports
the whole file as corrupt, which is why the deck would not open.

- Replaced the native chart with bars drawn as shapes: same five values
  to the same 0-100 scale, no chart part and no embedded workbook
- Stripped empty zip directory entries left by the generator
- Verified: no chart or embedding parts remain, all XML parses, all 17
  slides and notes intact, no off-slide shapes

Co-Authored-By: Claude Opus 5 <noreply@anthropic.com>
Claude-Session: https://claude.ai/code/session_01BpZQdqDUKJCNix1mZn7CYd
</commit_message>
<xml_diff>
--- a/pitch/Splendid_Spoon_Pitch_Deck.pptx
+++ b/pitch/Splendid_Spoon_Pitch_Deck.pptx
@@ -123,37 +123,37 @@
   <p:extLst>
     <p:ext uri="{521415D9-36F7-43E2-AB2F-B90AF26B5E84}">
       <p14:sectionLst xmlns:p14="http://schemas.microsoft.com/office/powerpoint/2010/main">
-        <p14:section name="Open" id="{b5c4f985-0f6c-86d9-d540-ad3e5468c7a8}">
+        <p14:section name="Open" id="{c3e5f638-5227-cb61-c20f-3d2c9afb5070}">
           <p14:sldIdLst>
             <p14:sldId id="256"/>
           </p14:sldIdLst>
         </p14:section>
-        <p14:section name="Situation" id="{bbf7c1be-7d12-beff-3976-0dcabe7acb6b}">
+        <p14:section name="Situation" id="{2de0a888-01fb-b7b4-30db-74e93f0f7b36}">
           <p14:sldIdLst>
             <p14:sldId id="257"/>
             <p14:sldId id="258"/>
             <p14:sldId id="259"/>
           </p14:sldIdLst>
         </p14:section>
-        <p14:section name="Audience" id="{590fad98-0ad7-f6ef-db85-7cacb57bab71}">
+        <p14:section name="Audience" id="{3292719d-d286-8794-a689-8095063f5562}">
           <p14:sldIdLst>
             <p14:sldId id="260"/>
             <p14:sldId id="261"/>
           </p14:sldIdLst>
         </p14:section>
-        <p14:section name="Strategy" id="{3aa0c4e6-224d-ec6a-da98-ed67c0a861ef}">
+        <p14:section name="Strategy" id="{4efd23f7-9370-ddc0-6a9c-b493c111b337}">
           <p14:sldIdLst>
             <p14:sldId id="262"/>
             <p14:sldId id="263"/>
           </p14:sldIdLst>
         </p14:section>
-        <p14:section name="Audit" id="{efa3feb5-81b1-1dc1-c3db-d822226b20a3}">
+        <p14:section name="Audit" id="{705ea4f8-86e4-86d2-6bf6-a4f924b1b825}">
           <p14:sldIdLst>
             <p14:sldId id="264"/>
             <p14:sldId id="265"/>
           </p14:sldIdLst>
         </p14:section>
-        <p14:section name="Recommendation" id="{0d5f86a2-a6a9-a5c6-72de-31a083efe72e}">
+        <p14:section name="Recommendation" id="{107017b2-9196-7a66-1a31-ead93992c062}">
           <p14:sldIdLst>
             <p14:sldId id="266"/>
             <p14:sldId id="267"/>
@@ -161,7 +161,7 @@
             <p14:sldId id="269"/>
           </p14:sldIdLst>
         </p14:section>
-        <p14:section name="Close" id="{df41b4a5-8aad-5308-c8d9-ad2fa6f37a7a}">
+        <p14:section name="Close" id="{148a67d9-3191-4e6e-0a10-46fa51a9e35a}">
           <p14:sldIdLst>
             <p14:sldId id="270"/>
             <p14:sldId id="271"/>
@@ -175,246 +175,6 @@
     </p:ext>
   </p:extLst>
 </p:presentation>
-</file>
-
-<file path=ppt/charts/chart1.xml><?xml version="1.0" encoding="utf-8"?>
-<c:chartSpace xmlns:c="http://schemas.openxmlformats.org/drawingml/2006/chart" xmlns:a="http://schemas.openxmlformats.org/drawingml/2006/main" xmlns:r="http://schemas.openxmlformats.org/officeDocument/2006/relationships">
-  <c:date1904 val="0"/>
-  <c:roundedCorners val="1"/>
-  <c:chart>
-    <c:autoTitleDeleted val="1"/>
-    <c:plotArea>
-      <c:layout/>
-      <c:barChart>
-        <c:barDir val="bar"/>
-        <c:grouping val="clustered"/>
-        <c:varyColors val="0"/>
-        <c:ser>
-          <c:idx val="0"/>
-          <c:order val="0"/>
-          <c:tx>
-            <c:strRef>
-              <c:f>Sheet1!$B$1</c:f>
-              <c:strCache>
-                <c:ptCount val="1"/>
-                <c:pt idx="0">
-                  <c:v>Share of U.S. adults who use the platform</c:v>
-                </c:pt>
-              </c:strCache>
-            </c:strRef>
-          </c:tx>
-          <c:spPr>
-            <a:solidFill>
-              <a:srgbClr val="2F7336"/>
-            </a:solidFill>
-            <a:effectLst/>
-          </c:spPr>
-          <c:invertIfNegative val="0"/>
-          <c:dLbls>
-            <c:numFmt formatCode="0&quot;%&quot;" sourceLinked="0"/>
-            <c:txPr>
-              <a:bodyPr/>
-              <a:lstStyle/>
-              <a:p>
-                <a:pPr>
-                  <a:defRPr b="0" i="0" strike="noStrike" sz="1300" u="none">
-                    <a:solidFill>
-                      <a:srgbClr val="14281B"/>
-                    </a:solidFill>
-                    <a:latin typeface="+mn-lt"/>
-                  </a:defRPr>
-                </a:pPr>
-              </a:p>
-            </c:txPr>
-            <c:showLegendKey val="0"/>
-            <c:showVal val="1"/>
-            <c:showCatName val="0"/>
-            <c:showSerName val="0"/>
-            <c:showPercent val="0"/>
-            <c:showBubbleSize val="0"/>
-            <c:showLeaderLines val="0"/>
-          </c:dLbls>
-          <c:cat>
-            <c:multiLvlStrRef>
-              <c:f>Sheet1!$A$2:$A$6</c:f>
-              <c:multiLvlStrCache>
-                <c:ptCount val="5"/>
-                <c:lvl>
-                  <c:pt idx="0">
-                    <c:v>YouTube</c:v>
-                  </c:pt>
-                  <c:pt idx="1">
-                    <c:v>Facebook</c:v>
-                  </c:pt>
-                  <c:pt idx="2">
-                    <c:v>Instagram</c:v>
-                  </c:pt>
-                  <c:pt idx="3">
-                    <c:v>TikTok</c:v>
-                  </c:pt>
-                  <c:pt idx="4">
-                    <c:v>Reddit</c:v>
-                  </c:pt>
-                </c:lvl>
-              </c:multiLvlStrCache>
-            </c:multiLvlStrRef>
-          </c:cat>
-          <c:val>
-            <c:numRef>
-              <c:f>Sheet1!$B$2:$B$6</c:f>
-              <c:numCache>
-                <c:formatCode>General</c:formatCode>
-                <c:ptCount val="5"/>
-                <c:pt idx="0">
-                  <c:v>84</c:v>
-                </c:pt>
-                <c:pt idx="1">
-                  <c:v>71</c:v>
-                </c:pt>
-                <c:pt idx="2">
-                  <c:v>50</c:v>
-                </c:pt>
-                <c:pt idx="3">
-                  <c:v>37</c:v>
-                </c:pt>
-                <c:pt idx="4">
-                  <c:v>26</c:v>
-                </c:pt>
-              </c:numCache>
-            </c:numRef>
-          </c:val>
-        </c:ser>
-        <c:dLbls>
-          <c:numFmt formatCode="0&quot;%&quot;" sourceLinked="0"/>
-          <c:txPr>
-            <a:bodyPr/>
-            <a:lstStyle/>
-            <a:p>
-              <a:pPr>
-                <a:defRPr b="0" i="0" strike="noStrike" sz="1300" u="none">
-                  <a:solidFill>
-                    <a:srgbClr val="14281B"/>
-                  </a:solidFill>
-                  <a:latin typeface="+mn-lt"/>
-                </a:defRPr>
-              </a:pPr>
-            </a:p>
-          </c:txPr>
-          <c:showLegendKey val="0"/>
-          <c:showVal val="1"/>
-          <c:showCatName val="0"/>
-          <c:showSerName val="0"/>
-          <c:showPercent val="0"/>
-          <c:showBubbleSize val="0"/>
-          <c:showLeaderLines val="0"/>
-        </c:dLbls>
-        <c:gapWidth val="45"/>
-        <c:overlap val="0"/>
-        <c:axId val="2094734554"/>
-        <c:axId val="2094734552"/>
-        <c:axId val="2094734556"/>
-      </c:barChart>
-      <c:catAx>
-        <c:axId val="2094734554"/>
-        <c:scaling>
-          <c:orientation val="minMax"/>
-        </c:scaling>
-        <c:delete val="0"/>
-        <c:axPos val="l"/>
-        <c:numFmt formatCode="General" sourceLinked="1"/>
-        <c:majorTickMark val="out"/>
-        <c:minorTickMark val="none"/>
-        <c:tickLblPos val="nextTo"/>
-        <c:spPr>
-          <a:ln w="12700" cap="flat">
-            <a:noFill/>
-            <a:prstDash val="solid"/>
-            <a:round/>
-          </a:ln>
-        </c:spPr>
-        <c:txPr>
-          <a:bodyPr/>
-          <a:lstStyle/>
-          <a:p>
-            <a:pPr>
-              <a:defRPr sz="1300" b="0" i="0" u="none" strike="noStrike">
-                <a:solidFill>
-                  <a:srgbClr val="14281B"/>
-                </a:solidFill>
-                <a:latin typeface="+mn-lt"/>
-              </a:defRPr>
-            </a:pPr>
-            <a:endParaRPr lang="en-US"/>
-          </a:p>
-        </c:txPr>
-        <c:crossAx val="2094734552"/>
-        <c:crosses val="autoZero"/>
-        <c:auto val="1"/>
-        <c:lblAlgn val="ctr"/>
-        <c:noMultiLvlLbl val="1"/>
-      </c:catAx>
-      <c:valAx>
-        <c:axId val="2094734552"/>
-        <c:scaling>
-          <c:orientation val="minMax"/>
-          <c:max val="100"/>
-        </c:scaling>
-        <c:delete val="1"/>
-        <c:axPos val="b"/>
-        <c:numFmt formatCode="General" sourceLinked="0"/>
-        <c:majorTickMark val="out"/>
-        <c:minorTickMark val="none"/>
-        <c:tickLblPos val="low"/>
-        <c:spPr>
-          <a:ln w="12700" cap="flat">
-            <a:noFill/>
-            <a:prstDash val="solid"/>
-            <a:round/>
-          </a:ln>
-        </c:spPr>
-        <c:txPr>
-          <a:bodyPr/>
-          <a:lstStyle/>
-          <a:p>
-            <a:pPr>
-              <a:defRPr sz="1200" b="0" i="0" u="none" strike="noStrike">
-                <a:solidFill>
-                  <a:srgbClr val="000000"/>
-                </a:solidFill>
-                <a:latin typeface="Arial"/>
-              </a:defRPr>
-            </a:pPr>
-            <a:endParaRPr lang="en-US"/>
-          </a:p>
-        </c:txPr>
-        <c:crossAx val="2094734554"/>
-        <c:crosses val="autoZero"/>
-        <c:crossBetween val="between"/>
-      </c:valAx>
-      <c:spPr>
-        <a:solidFill>
-          <a:srgbClr val="FFFFFF"/>
-        </a:solidFill>
-        <a:ln>
-          <a:noFill/>
-        </a:ln>
-        <a:effectLst/>
-      </c:spPr>
-    </c:plotArea>
-    <c:plotVisOnly val="1"/>
-    <c:dispBlanksAs val="span"/>
-  </c:chart>
-  <c:spPr>
-    <a:noFill/>
-    <a:ln>
-      <a:noFill/>
-    </a:ln>
-    <a:effectLst/>
-  </c:spPr>
-  <c:externalData r:id="rId1">
-    <c:autoUpdate val="0"/>
-  </c:externalData>
-</c:chartSpace>
 </file>
 
 <file path=ppt/notesMasters/notesMaster1.xml><?xml version="1.0" encoding="utf-8"?>
@@ -11240,76 +11000,58 @@
           </a:p>
         </p:txBody>
       </p:sp>
-      <p:graphicFrame>
-        <p:nvGraphicFramePr>
-          <p:cNvPr id="3" name="Chart 0" descr=""/>
-          <p:cNvGraphicFramePr/>
-          <p:nvPr/>
-        </p:nvGraphicFramePr>
-        <p:xfrm>
-          <a:off x="685800" y="1371600"/>
-          <a:ext cx="6949440" cy="4206240"/>
-        </p:xfrm>
-        <a:graphic xmlns:a="http://schemas.openxmlformats.org/drawingml/2006/main">
-          <a:graphicData uri="http://schemas.openxmlformats.org/drawingml/2006/chart">
-            <c:chart xmlns:c="http://schemas.openxmlformats.org/drawingml/2006/chart" r:id="rId1"/>
-          </a:graphicData>
-        </a:graphic>
-      </p:graphicFrame>
-      <p:sp>
-        <p:nvSpPr>
-          <p:cNvPr id="4" name="Text 1"/>
-          <p:cNvSpPr txBox="1"/>
-          <p:nvPr/>
-        </p:nvSpPr>
-        <p:spPr>
-          <a:xfrm>
-            <a:off x="685800" y="5669280"/>
-            <a:ext cx="6949440" cy="274320"/>
-          </a:xfrm>
-          <a:prstGeom prst="rect">
-            <a:avLst/>
-          </a:prstGeom>
-          <a:noFill/>
-          <a:ln/>
-        </p:spPr>
-        <p:txBody>
-          <a:bodyPr wrap="square" rtlCol="0" anchor="ctr"/>
-          <a:lstStyle/>
-          <a:p>
-            <a:pPr indent="0" marL="0">
-              <a:buNone/>
-            </a:pPr>
-            <a:r>
-              <a:rPr lang="en-US" sz="1000" dirty="0">
-                <a:solidFill>
-                  <a:srgbClr val="6E7B66"/>
+      <p:sp>
+        <p:nvSpPr>
+          <p:cNvPr id="3" name="Text 1"/>
+          <p:cNvSpPr txBox="1"/>
+          <p:nvPr/>
+        </p:nvSpPr>
+        <p:spPr>
+          <a:xfrm>
+            <a:off x="685800" y="1783080"/>
+            <a:ext cx="1371600" cy="384048"/>
+          </a:xfrm>
+          <a:prstGeom prst="rect">
+            <a:avLst/>
+          </a:prstGeom>
+          <a:noFill/>
+          <a:ln/>
+        </p:spPr>
+        <p:txBody>
+          <a:bodyPr wrap="square" lIns="0" tIns="0" rIns="0" bIns="0" rtlCol="0" anchor="ctr"/>
+          <a:lstStyle/>
+          <a:p>
+            <a:pPr indent="0" marL="0">
+              <a:buNone/>
+            </a:pPr>
+            <a:r>
+              <a:rPr lang="en-US" sz="1300" dirty="0">
+                <a:solidFill>
+                  <a:srgbClr val="14281B"/>
                 </a:solidFill>
                 <a:latin typeface="Calibri" pitchFamily="34" charset="0"/>
                 <a:ea typeface="Calibri" pitchFamily="34" charset="-122"/>
                 <a:cs typeface="Calibri" pitchFamily="34" charset="-120"/>
               </a:rPr>
-              <a:t>Pew Research Center, 2025</a:t>
-            </a:r>
-            <a:endParaRPr lang="en-US" sz="1000" dirty="0"/>
-          </a:p>
-        </p:txBody>
-      </p:sp>
-      <p:sp>
-        <p:nvSpPr>
-          <p:cNvPr id="5" name="reach-note"/>
+              <a:t>YouTube</a:t>
+            </a:r>
+            <a:endParaRPr lang="en-US" sz="1300" dirty="0"/>
+          </a:p>
+        </p:txBody>
+      </p:sp>
+      <p:sp>
+        <p:nvSpPr>
+          <p:cNvPr id="4" name="track-YouTube"/>
           <p:cNvSpPr/>
           <p:nvPr/>
         </p:nvSpPr>
         <p:spPr>
           <a:xfrm>
-            <a:off x="7955280" y="1737360"/>
-            <a:ext cx="3520440" cy="3200400"/>
-          </a:xfrm>
-          <a:prstGeom prst="roundRect">
-            <a:avLst>
-              <a:gd name="adj" fmla="val 3429"/>
-            </a:avLst>
+            <a:off x="2148840" y="1783080"/>
+            <a:ext cx="4572000" cy="384048"/>
+          </a:xfrm>
+          <a:prstGeom prst="rect">
+            <a:avLst/>
           </a:prstGeom>
           <a:solidFill>
             <a:srgbClr val="F1F5EE"/>
@@ -11324,7 +11066,688 @@
       </p:sp>
       <p:sp>
         <p:nvSpPr>
-          <p:cNvPr id="6" name="Text 3"/>
+          <p:cNvPr id="5" name="bar-YouTube"/>
+          <p:cNvSpPr/>
+          <p:nvPr/>
+        </p:nvSpPr>
+        <p:spPr>
+          <a:xfrm>
+            <a:off x="2148840" y="1783080"/>
+            <a:ext cx="3840480" cy="384048"/>
+          </a:xfrm>
+          <a:prstGeom prst="rect">
+            <a:avLst/>
+          </a:prstGeom>
+          <a:solidFill>
+            <a:srgbClr val="2F7336"/>
+          </a:solidFill>
+          <a:ln w="12700">
+            <a:solidFill>
+              <a:srgbClr val="2F7336"/>
+            </a:solidFill>
+            <a:prstDash val="solid"/>
+          </a:ln>
+        </p:spPr>
+      </p:sp>
+      <p:sp>
+        <p:nvSpPr>
+          <p:cNvPr id="6" name="Text 4"/>
+          <p:cNvSpPr txBox="1"/>
+          <p:nvPr/>
+        </p:nvSpPr>
+        <p:spPr>
+          <a:xfrm>
+            <a:off x="6858000" y="1783080"/>
+            <a:ext cx="731520" cy="384048"/>
+          </a:xfrm>
+          <a:prstGeom prst="rect">
+            <a:avLst/>
+          </a:prstGeom>
+          <a:noFill/>
+          <a:ln/>
+        </p:spPr>
+        <p:txBody>
+          <a:bodyPr wrap="square" lIns="0" tIns="0" rIns="0" bIns="0" rtlCol="0" anchor="ctr"/>
+          <a:lstStyle/>
+          <a:p>
+            <a:pPr indent="0" marL="0">
+              <a:buNone/>
+            </a:pPr>
+            <a:r>
+              <a:rPr lang="en-US" sz="1300" b="1" dirty="0">
+                <a:solidFill>
+                  <a:srgbClr val="14281B"/>
+                </a:solidFill>
+                <a:latin typeface="Calibri" pitchFamily="34" charset="0"/>
+                <a:ea typeface="Calibri" pitchFamily="34" charset="-122"/>
+                <a:cs typeface="Calibri" pitchFamily="34" charset="-120"/>
+              </a:rPr>
+              <a:t>84%</a:t>
+            </a:r>
+            <a:endParaRPr lang="en-US" sz="1300" dirty="0"/>
+          </a:p>
+        </p:txBody>
+      </p:sp>
+      <p:sp>
+        <p:nvSpPr>
+          <p:cNvPr id="7" name="Text 5"/>
+          <p:cNvSpPr txBox="1"/>
+          <p:nvPr/>
+        </p:nvSpPr>
+        <p:spPr>
+          <a:xfrm>
+            <a:off x="685800" y="2569464"/>
+            <a:ext cx="1371600" cy="384048"/>
+          </a:xfrm>
+          <a:prstGeom prst="rect">
+            <a:avLst/>
+          </a:prstGeom>
+          <a:noFill/>
+          <a:ln/>
+        </p:spPr>
+        <p:txBody>
+          <a:bodyPr wrap="square" lIns="0" tIns="0" rIns="0" bIns="0" rtlCol="0" anchor="ctr"/>
+          <a:lstStyle/>
+          <a:p>
+            <a:pPr indent="0" marL="0">
+              <a:buNone/>
+            </a:pPr>
+            <a:r>
+              <a:rPr lang="en-US" sz="1300" dirty="0">
+                <a:solidFill>
+                  <a:srgbClr val="14281B"/>
+                </a:solidFill>
+                <a:latin typeface="Calibri" pitchFamily="34" charset="0"/>
+                <a:ea typeface="Calibri" pitchFamily="34" charset="-122"/>
+                <a:cs typeface="Calibri" pitchFamily="34" charset="-120"/>
+              </a:rPr>
+              <a:t>Facebook</a:t>
+            </a:r>
+            <a:endParaRPr lang="en-US" sz="1300" dirty="0"/>
+          </a:p>
+        </p:txBody>
+      </p:sp>
+      <p:sp>
+        <p:nvSpPr>
+          <p:cNvPr id="8" name="track-Facebook"/>
+          <p:cNvSpPr/>
+          <p:nvPr/>
+        </p:nvSpPr>
+        <p:spPr>
+          <a:xfrm>
+            <a:off x="2148840" y="2569464"/>
+            <a:ext cx="4572000" cy="384048"/>
+          </a:xfrm>
+          <a:prstGeom prst="rect">
+            <a:avLst/>
+          </a:prstGeom>
+          <a:solidFill>
+            <a:srgbClr val="F1F5EE"/>
+          </a:solidFill>
+          <a:ln w="12700">
+            <a:solidFill>
+              <a:srgbClr val="F1F5EE"/>
+            </a:solidFill>
+            <a:prstDash val="solid"/>
+          </a:ln>
+        </p:spPr>
+      </p:sp>
+      <p:sp>
+        <p:nvSpPr>
+          <p:cNvPr id="9" name="bar-Facebook"/>
+          <p:cNvSpPr/>
+          <p:nvPr/>
+        </p:nvSpPr>
+        <p:spPr>
+          <a:xfrm>
+            <a:off x="2148840" y="2569464"/>
+            <a:ext cx="3246120" cy="384048"/>
+          </a:xfrm>
+          <a:prstGeom prst="rect">
+            <a:avLst/>
+          </a:prstGeom>
+          <a:solidFill>
+            <a:srgbClr val="2F7336"/>
+          </a:solidFill>
+          <a:ln w="12700">
+            <a:solidFill>
+              <a:srgbClr val="2F7336"/>
+            </a:solidFill>
+            <a:prstDash val="solid"/>
+          </a:ln>
+        </p:spPr>
+      </p:sp>
+      <p:sp>
+        <p:nvSpPr>
+          <p:cNvPr id="10" name="Text 8"/>
+          <p:cNvSpPr txBox="1"/>
+          <p:nvPr/>
+        </p:nvSpPr>
+        <p:spPr>
+          <a:xfrm>
+            <a:off x="6858000" y="2569464"/>
+            <a:ext cx="731520" cy="384048"/>
+          </a:xfrm>
+          <a:prstGeom prst="rect">
+            <a:avLst/>
+          </a:prstGeom>
+          <a:noFill/>
+          <a:ln/>
+        </p:spPr>
+        <p:txBody>
+          <a:bodyPr wrap="square" lIns="0" tIns="0" rIns="0" bIns="0" rtlCol="0" anchor="ctr"/>
+          <a:lstStyle/>
+          <a:p>
+            <a:pPr indent="0" marL="0">
+              <a:buNone/>
+            </a:pPr>
+            <a:r>
+              <a:rPr lang="en-US" sz="1300" b="1" dirty="0">
+                <a:solidFill>
+                  <a:srgbClr val="14281B"/>
+                </a:solidFill>
+                <a:latin typeface="Calibri" pitchFamily="34" charset="0"/>
+                <a:ea typeface="Calibri" pitchFamily="34" charset="-122"/>
+                <a:cs typeface="Calibri" pitchFamily="34" charset="-120"/>
+              </a:rPr>
+              <a:t>71%</a:t>
+            </a:r>
+            <a:endParaRPr lang="en-US" sz="1300" dirty="0"/>
+          </a:p>
+        </p:txBody>
+      </p:sp>
+      <p:sp>
+        <p:nvSpPr>
+          <p:cNvPr id="11" name="Text 9"/>
+          <p:cNvSpPr txBox="1"/>
+          <p:nvPr/>
+        </p:nvSpPr>
+        <p:spPr>
+          <a:xfrm>
+            <a:off x="685800" y="3355848"/>
+            <a:ext cx="1371600" cy="384048"/>
+          </a:xfrm>
+          <a:prstGeom prst="rect">
+            <a:avLst/>
+          </a:prstGeom>
+          <a:noFill/>
+          <a:ln/>
+        </p:spPr>
+        <p:txBody>
+          <a:bodyPr wrap="square" lIns="0" tIns="0" rIns="0" bIns="0" rtlCol="0" anchor="ctr"/>
+          <a:lstStyle/>
+          <a:p>
+            <a:pPr indent="0" marL="0">
+              <a:buNone/>
+            </a:pPr>
+            <a:r>
+              <a:rPr lang="en-US" sz="1300" dirty="0">
+                <a:solidFill>
+                  <a:srgbClr val="14281B"/>
+                </a:solidFill>
+                <a:latin typeface="Calibri" pitchFamily="34" charset="0"/>
+                <a:ea typeface="Calibri" pitchFamily="34" charset="-122"/>
+                <a:cs typeface="Calibri" pitchFamily="34" charset="-120"/>
+              </a:rPr>
+              <a:t>Instagram</a:t>
+            </a:r>
+            <a:endParaRPr lang="en-US" sz="1300" dirty="0"/>
+          </a:p>
+        </p:txBody>
+      </p:sp>
+      <p:sp>
+        <p:nvSpPr>
+          <p:cNvPr id="12" name="track-Instagram"/>
+          <p:cNvSpPr/>
+          <p:nvPr/>
+        </p:nvSpPr>
+        <p:spPr>
+          <a:xfrm>
+            <a:off x="2148840" y="3355848"/>
+            <a:ext cx="4572000" cy="384048"/>
+          </a:xfrm>
+          <a:prstGeom prst="rect">
+            <a:avLst/>
+          </a:prstGeom>
+          <a:solidFill>
+            <a:srgbClr val="F1F5EE"/>
+          </a:solidFill>
+          <a:ln w="12700">
+            <a:solidFill>
+              <a:srgbClr val="F1F5EE"/>
+            </a:solidFill>
+            <a:prstDash val="solid"/>
+          </a:ln>
+        </p:spPr>
+      </p:sp>
+      <p:sp>
+        <p:nvSpPr>
+          <p:cNvPr id="13" name="bar-Instagram"/>
+          <p:cNvSpPr/>
+          <p:nvPr/>
+        </p:nvSpPr>
+        <p:spPr>
+          <a:xfrm>
+            <a:off x="2148840" y="3355848"/>
+            <a:ext cx="2286000" cy="384048"/>
+          </a:xfrm>
+          <a:prstGeom prst="rect">
+            <a:avLst/>
+          </a:prstGeom>
+          <a:solidFill>
+            <a:srgbClr val="2F7336"/>
+          </a:solidFill>
+          <a:ln w="12700">
+            <a:solidFill>
+              <a:srgbClr val="2F7336"/>
+            </a:solidFill>
+            <a:prstDash val="solid"/>
+          </a:ln>
+        </p:spPr>
+      </p:sp>
+      <p:sp>
+        <p:nvSpPr>
+          <p:cNvPr id="14" name="Text 12"/>
+          <p:cNvSpPr txBox="1"/>
+          <p:nvPr/>
+        </p:nvSpPr>
+        <p:spPr>
+          <a:xfrm>
+            <a:off x="6858000" y="3355848"/>
+            <a:ext cx="731520" cy="384048"/>
+          </a:xfrm>
+          <a:prstGeom prst="rect">
+            <a:avLst/>
+          </a:prstGeom>
+          <a:noFill/>
+          <a:ln/>
+        </p:spPr>
+        <p:txBody>
+          <a:bodyPr wrap="square" lIns="0" tIns="0" rIns="0" bIns="0" rtlCol="0" anchor="ctr"/>
+          <a:lstStyle/>
+          <a:p>
+            <a:pPr indent="0" marL="0">
+              <a:buNone/>
+            </a:pPr>
+            <a:r>
+              <a:rPr lang="en-US" sz="1300" b="1" dirty="0">
+                <a:solidFill>
+                  <a:srgbClr val="14281B"/>
+                </a:solidFill>
+                <a:latin typeface="Calibri" pitchFamily="34" charset="0"/>
+                <a:ea typeface="Calibri" pitchFamily="34" charset="-122"/>
+                <a:cs typeface="Calibri" pitchFamily="34" charset="-120"/>
+              </a:rPr>
+              <a:t>50%</a:t>
+            </a:r>
+            <a:endParaRPr lang="en-US" sz="1300" dirty="0"/>
+          </a:p>
+        </p:txBody>
+      </p:sp>
+      <p:sp>
+        <p:nvSpPr>
+          <p:cNvPr id="15" name="Text 13"/>
+          <p:cNvSpPr txBox="1"/>
+          <p:nvPr/>
+        </p:nvSpPr>
+        <p:spPr>
+          <a:xfrm>
+            <a:off x="685800" y="4142232"/>
+            <a:ext cx="1371600" cy="384048"/>
+          </a:xfrm>
+          <a:prstGeom prst="rect">
+            <a:avLst/>
+          </a:prstGeom>
+          <a:noFill/>
+          <a:ln/>
+        </p:spPr>
+        <p:txBody>
+          <a:bodyPr wrap="square" lIns="0" tIns="0" rIns="0" bIns="0" rtlCol="0" anchor="ctr"/>
+          <a:lstStyle/>
+          <a:p>
+            <a:pPr indent="0" marL="0">
+              <a:buNone/>
+            </a:pPr>
+            <a:r>
+              <a:rPr lang="en-US" sz="1300" dirty="0">
+                <a:solidFill>
+                  <a:srgbClr val="14281B"/>
+                </a:solidFill>
+                <a:latin typeface="Calibri" pitchFamily="34" charset="0"/>
+                <a:ea typeface="Calibri" pitchFamily="34" charset="-122"/>
+                <a:cs typeface="Calibri" pitchFamily="34" charset="-120"/>
+              </a:rPr>
+              <a:t>TikTok</a:t>
+            </a:r>
+            <a:endParaRPr lang="en-US" sz="1300" dirty="0"/>
+          </a:p>
+        </p:txBody>
+      </p:sp>
+      <p:sp>
+        <p:nvSpPr>
+          <p:cNvPr id="16" name="track-TikTok"/>
+          <p:cNvSpPr/>
+          <p:nvPr/>
+        </p:nvSpPr>
+        <p:spPr>
+          <a:xfrm>
+            <a:off x="2148840" y="4142232"/>
+            <a:ext cx="4572000" cy="384048"/>
+          </a:xfrm>
+          <a:prstGeom prst="rect">
+            <a:avLst/>
+          </a:prstGeom>
+          <a:solidFill>
+            <a:srgbClr val="F1F5EE"/>
+          </a:solidFill>
+          <a:ln w="12700">
+            <a:solidFill>
+              <a:srgbClr val="F1F5EE"/>
+            </a:solidFill>
+            <a:prstDash val="solid"/>
+          </a:ln>
+        </p:spPr>
+      </p:sp>
+      <p:sp>
+        <p:nvSpPr>
+          <p:cNvPr id="17" name="bar-TikTok"/>
+          <p:cNvSpPr/>
+          <p:nvPr/>
+        </p:nvSpPr>
+        <p:spPr>
+          <a:xfrm>
+            <a:off x="2148840" y="4142232"/>
+            <a:ext cx="1691640" cy="384048"/>
+          </a:xfrm>
+          <a:prstGeom prst="rect">
+            <a:avLst/>
+          </a:prstGeom>
+          <a:solidFill>
+            <a:srgbClr val="2F7336"/>
+          </a:solidFill>
+          <a:ln w="12700">
+            <a:solidFill>
+              <a:srgbClr val="2F7336"/>
+            </a:solidFill>
+            <a:prstDash val="solid"/>
+          </a:ln>
+        </p:spPr>
+      </p:sp>
+      <p:sp>
+        <p:nvSpPr>
+          <p:cNvPr id="18" name="Text 16"/>
+          <p:cNvSpPr txBox="1"/>
+          <p:nvPr/>
+        </p:nvSpPr>
+        <p:spPr>
+          <a:xfrm>
+            <a:off x="6858000" y="4142232"/>
+            <a:ext cx="731520" cy="384048"/>
+          </a:xfrm>
+          <a:prstGeom prst="rect">
+            <a:avLst/>
+          </a:prstGeom>
+          <a:noFill/>
+          <a:ln/>
+        </p:spPr>
+        <p:txBody>
+          <a:bodyPr wrap="square" lIns="0" tIns="0" rIns="0" bIns="0" rtlCol="0" anchor="ctr"/>
+          <a:lstStyle/>
+          <a:p>
+            <a:pPr indent="0" marL="0">
+              <a:buNone/>
+            </a:pPr>
+            <a:r>
+              <a:rPr lang="en-US" sz="1300" b="1" dirty="0">
+                <a:solidFill>
+                  <a:srgbClr val="14281B"/>
+                </a:solidFill>
+                <a:latin typeface="Calibri" pitchFamily="34" charset="0"/>
+                <a:ea typeface="Calibri" pitchFamily="34" charset="-122"/>
+                <a:cs typeface="Calibri" pitchFamily="34" charset="-120"/>
+              </a:rPr>
+              <a:t>37%</a:t>
+            </a:r>
+            <a:endParaRPr lang="en-US" sz="1300" dirty="0"/>
+          </a:p>
+        </p:txBody>
+      </p:sp>
+      <p:sp>
+        <p:nvSpPr>
+          <p:cNvPr id="19" name="Text 17"/>
+          <p:cNvSpPr txBox="1"/>
+          <p:nvPr/>
+        </p:nvSpPr>
+        <p:spPr>
+          <a:xfrm>
+            <a:off x="685800" y="4928616"/>
+            <a:ext cx="1371600" cy="384048"/>
+          </a:xfrm>
+          <a:prstGeom prst="rect">
+            <a:avLst/>
+          </a:prstGeom>
+          <a:noFill/>
+          <a:ln/>
+        </p:spPr>
+        <p:txBody>
+          <a:bodyPr wrap="square" lIns="0" tIns="0" rIns="0" bIns="0" rtlCol="0" anchor="ctr"/>
+          <a:lstStyle/>
+          <a:p>
+            <a:pPr indent="0" marL="0">
+              <a:buNone/>
+            </a:pPr>
+            <a:r>
+              <a:rPr lang="en-US" sz="1300" dirty="0">
+                <a:solidFill>
+                  <a:srgbClr val="14281B"/>
+                </a:solidFill>
+                <a:latin typeface="Calibri" pitchFamily="34" charset="0"/>
+                <a:ea typeface="Calibri" pitchFamily="34" charset="-122"/>
+                <a:cs typeface="Calibri" pitchFamily="34" charset="-120"/>
+              </a:rPr>
+              <a:t>Reddit</a:t>
+            </a:r>
+            <a:endParaRPr lang="en-US" sz="1300" dirty="0"/>
+          </a:p>
+        </p:txBody>
+      </p:sp>
+      <p:sp>
+        <p:nvSpPr>
+          <p:cNvPr id="20" name="track-Reddit"/>
+          <p:cNvSpPr/>
+          <p:nvPr/>
+        </p:nvSpPr>
+        <p:spPr>
+          <a:xfrm>
+            <a:off x="2148840" y="4928616"/>
+            <a:ext cx="4572000" cy="384048"/>
+          </a:xfrm>
+          <a:prstGeom prst="rect">
+            <a:avLst/>
+          </a:prstGeom>
+          <a:solidFill>
+            <a:srgbClr val="F1F5EE"/>
+          </a:solidFill>
+          <a:ln w="12700">
+            <a:solidFill>
+              <a:srgbClr val="F1F5EE"/>
+            </a:solidFill>
+            <a:prstDash val="solid"/>
+          </a:ln>
+        </p:spPr>
+      </p:sp>
+      <p:sp>
+        <p:nvSpPr>
+          <p:cNvPr id="21" name="bar-Reddit"/>
+          <p:cNvSpPr/>
+          <p:nvPr/>
+        </p:nvSpPr>
+        <p:spPr>
+          <a:xfrm>
+            <a:off x="2148840" y="4928616"/>
+            <a:ext cx="1188720" cy="384048"/>
+          </a:xfrm>
+          <a:prstGeom prst="rect">
+            <a:avLst/>
+          </a:prstGeom>
+          <a:solidFill>
+            <a:srgbClr val="2F7336"/>
+          </a:solidFill>
+          <a:ln w="12700">
+            <a:solidFill>
+              <a:srgbClr val="2F7336"/>
+            </a:solidFill>
+            <a:prstDash val="solid"/>
+          </a:ln>
+        </p:spPr>
+      </p:sp>
+      <p:sp>
+        <p:nvSpPr>
+          <p:cNvPr id="22" name="Text 20"/>
+          <p:cNvSpPr txBox="1"/>
+          <p:nvPr/>
+        </p:nvSpPr>
+        <p:spPr>
+          <a:xfrm>
+            <a:off x="6858000" y="4928616"/>
+            <a:ext cx="731520" cy="384048"/>
+          </a:xfrm>
+          <a:prstGeom prst="rect">
+            <a:avLst/>
+          </a:prstGeom>
+          <a:noFill/>
+          <a:ln/>
+        </p:spPr>
+        <p:txBody>
+          <a:bodyPr wrap="square" lIns="0" tIns="0" rIns="0" bIns="0" rtlCol="0" anchor="ctr"/>
+          <a:lstStyle/>
+          <a:p>
+            <a:pPr indent="0" marL="0">
+              <a:buNone/>
+            </a:pPr>
+            <a:r>
+              <a:rPr lang="en-US" sz="1300" b="1" dirty="0">
+                <a:solidFill>
+                  <a:srgbClr val="14281B"/>
+                </a:solidFill>
+                <a:latin typeface="Calibri" pitchFamily="34" charset="0"/>
+                <a:ea typeface="Calibri" pitchFamily="34" charset="-122"/>
+                <a:cs typeface="Calibri" pitchFamily="34" charset="-120"/>
+              </a:rPr>
+              <a:t>26%</a:t>
+            </a:r>
+            <a:endParaRPr lang="en-US" sz="1300" dirty="0"/>
+          </a:p>
+        </p:txBody>
+      </p:sp>
+      <p:sp>
+        <p:nvSpPr>
+          <p:cNvPr id="23" name="Text 21"/>
+          <p:cNvSpPr txBox="1"/>
+          <p:nvPr/>
+        </p:nvSpPr>
+        <p:spPr>
+          <a:xfrm>
+            <a:off x="685800" y="5806440"/>
+            <a:ext cx="6949440" cy="274320"/>
+          </a:xfrm>
+          <a:prstGeom prst="rect">
+            <a:avLst/>
+          </a:prstGeom>
+          <a:noFill/>
+          <a:ln/>
+        </p:spPr>
+        <p:txBody>
+          <a:bodyPr wrap="square" rtlCol="0" anchor="ctr"/>
+          <a:lstStyle/>
+          <a:p>
+            <a:pPr indent="0" marL="0">
+              <a:buNone/>
+            </a:pPr>
+            <a:r>
+              <a:rPr lang="en-US" sz="1100" dirty="0">
+                <a:solidFill>
+                  <a:srgbClr val="6E7B66"/>
+                </a:solidFill>
+                <a:latin typeface="Calibri" pitchFamily="34" charset="0"/>
+                <a:ea typeface="Calibri" pitchFamily="34" charset="-122"/>
+                <a:cs typeface="Calibri" pitchFamily="34" charset="-120"/>
+              </a:rPr>
+              <a:t>Share of U.S. adults who use each platform</a:t>
+            </a:r>
+            <a:endParaRPr lang="en-US" sz="1100" dirty="0"/>
+          </a:p>
+        </p:txBody>
+      </p:sp>
+      <p:sp>
+        <p:nvSpPr>
+          <p:cNvPr id="24" name="Text 22"/>
+          <p:cNvSpPr txBox="1"/>
+          <p:nvPr/>
+        </p:nvSpPr>
+        <p:spPr>
+          <a:xfrm>
+            <a:off x="685800" y="6053328"/>
+            <a:ext cx="6949440" cy="274320"/>
+          </a:xfrm>
+          <a:prstGeom prst="rect">
+            <a:avLst/>
+          </a:prstGeom>
+          <a:noFill/>
+          <a:ln/>
+        </p:spPr>
+        <p:txBody>
+          <a:bodyPr wrap="square" rtlCol="0" anchor="ctr"/>
+          <a:lstStyle/>
+          <a:p>
+            <a:pPr indent="0" marL="0">
+              <a:buNone/>
+            </a:pPr>
+            <a:r>
+              <a:rPr lang="en-US" sz="1000" dirty="0">
+                <a:solidFill>
+                  <a:srgbClr val="6E7B66"/>
+                </a:solidFill>
+                <a:latin typeface="Calibri" pitchFamily="34" charset="0"/>
+                <a:ea typeface="Calibri" pitchFamily="34" charset="-122"/>
+                <a:cs typeface="Calibri" pitchFamily="34" charset="-120"/>
+              </a:rPr>
+              <a:t>Pew Research Center, 2025</a:t>
+            </a:r>
+            <a:endParaRPr lang="en-US" sz="1000" dirty="0"/>
+          </a:p>
+        </p:txBody>
+      </p:sp>
+      <p:sp>
+        <p:nvSpPr>
+          <p:cNvPr id="25" name="reach-note"/>
+          <p:cNvSpPr/>
+          <p:nvPr/>
+        </p:nvSpPr>
+        <p:spPr>
+          <a:xfrm>
+            <a:off x="7955280" y="1737360"/>
+            <a:ext cx="3520440" cy="3200400"/>
+          </a:xfrm>
+          <a:prstGeom prst="roundRect">
+            <a:avLst>
+              <a:gd name="adj" fmla="val 3429"/>
+            </a:avLst>
+          </a:prstGeom>
+          <a:solidFill>
+            <a:srgbClr val="F1F5EE"/>
+          </a:solidFill>
+          <a:ln w="12700">
+            <a:solidFill>
+              <a:srgbClr val="F1F5EE"/>
+            </a:solidFill>
+            <a:prstDash val="solid"/>
+          </a:ln>
+        </p:spPr>
+      </p:sp>
+      <p:sp>
+        <p:nvSpPr>
+          <p:cNvPr id="26" name="Text 24"/>
           <p:cNvSpPr txBox="1"/>
           <p:nvPr/>
         </p:nvSpPr>
@@ -11366,7 +11789,7 @@
       </p:sp>
       <p:sp>
         <p:nvSpPr>
-          <p:cNvPr id="7" name="Text 4"/>
+          <p:cNvPr id="27" name="Text 25"/>
           <p:cNvSpPr txBox="1"/>
           <p:nvPr/>
         </p:nvSpPr>

</xml_diff>